<commit_message>
docs(pptx): include Mathew Alarcon in proponents list on Slide 1 and ViziSlides prompt
</commit_message>
<xml_diff>
--- a/TARIPA_Defense_Presentation.pptx
+++ b/TARIPA_Defense_Presentation.pptx
@@ -1943,7 +1943,7 @@
               <a:buNone/>
             </a:pPr>
             <a:r>
-              <a:rPr lang="en-US" sz="1500" b="1" dirty="0">
+              <a:rPr lang="en-US" sz="1400" b="1" dirty="0">
                 <a:solidFill>
                   <a:srgbClr val="FFFFFF"/>
                 </a:solidFill>
@@ -1951,7 +1951,7 @@
                 <a:ea typeface="Segoe UI" pitchFamily="34" charset="-122"/>
                 <a:cs typeface="Segoe UI" pitchFamily="34" charset="-120"/>
               </a:rPr>
-              <a:t>James Sevilla  ·  Lorrely Paga
+              <a:t>James Sevilla  ·  Lorrely Paga  ·  Mathew Alarcon
 </a:t>
             </a:r>
             <a:pPr indent="0" marL="0">

</xml_diff>

<commit_message>
docs(pptx): replace embedded slides screenshots with updated UI views including Mathew Alarcon
</commit_message>
<xml_diff>
--- a/TARIPA_Defense_Presentation.pptx
+++ b/TARIPA_Defense_Presentation.pptx
@@ -2016,7 +2016,7 @@
       </p:sp>
       <p:pic>
         <p:nvPicPr>
-          <p:cNvPr id="10" name="Image 0" descr="C:\Users\Anastacia\.gemini\antigravity\brain\b231025d-bdec-4ae6-abf4-6612b4e70062\.user_uploaded\media_1791716225010_fcbfa63b.png">    </p:cNvPr>
+          <p:cNvPr id="10" name="Image 0" descr="C:\Users\Anastacia\.gemini\antigravity\brain\b231025d-bdec-4ae6-abf4-6612b4e70062\.user_uploaded\media_1791717718314_44f510c9.png">    </p:cNvPr>
           <p:cNvPicPr>
             <a:picLocks noChangeAspect="1"/>
           </p:cNvPicPr>
@@ -6206,7 +6206,7 @@
       </p:sp>
       <p:pic>
         <p:nvPicPr>
-          <p:cNvPr id="27" name="Image 0" descr="C:\Users\Anastacia\.gemini\antigravity\brain\b231025d-bdec-4ae6-abf4-6612b4e70062\.user_uploaded\media_1791716316961_c803d0d0.png">    </p:cNvPr>
+          <p:cNvPr id="27" name="Image 0" descr="C:\Users\Anastacia\.gemini\antigravity\brain\b231025d-bdec-4ae6-abf4-6612b4e70062\.user_uploaded\media_1791717676276_c325b3ec.png">    </p:cNvPr>
           <p:cNvPicPr>
             <a:picLocks noChangeAspect="1"/>
           </p:cNvPicPr>
@@ -6850,7 +6850,7 @@
       </p:sp>
       <p:pic>
         <p:nvPicPr>
-          <p:cNvPr id="19" name="Image 0" descr="C:\Users\Anastacia\.gemini\antigravity\brain\b231025d-bdec-4ae6-abf4-6612b4e70062\.user_uploaded\media_1791716303107_37320848.png">    </p:cNvPr>
+          <p:cNvPr id="19" name="Image 0" descr="C:\Users\Anastacia\.gemini\antigravity\brain\b231025d-bdec-4ae6-abf4-6612b4e70062\.user_uploaded\media_1791717623545_c44e2059.png">    </p:cNvPr>
           <p:cNvPicPr>
             <a:picLocks noChangeAspect="1"/>
           </p:cNvPicPr>
@@ -7389,7 +7389,7 @@
       </p:sp>
       <p:pic>
         <p:nvPicPr>
-          <p:cNvPr id="16" name="Image 0" descr="C:\Users\Anastacia\.gemini\antigravity\brain\b231025d-bdec-4ae6-abf4-6612b4e70062\.user_uploaded\media_1791716225010_fcbfa63b.png">    </p:cNvPr>
+          <p:cNvPr id="16" name="Image 0" descr="C:\Users\Anastacia\.gemini\antigravity\brain\b231025d-bdec-4ae6-abf4-6612b4e70062\.user_uploaded\media_1791717718314_44f510c9.png">    </p:cNvPr>
           <p:cNvPicPr>
             <a:picLocks noChangeAspect="1"/>
           </p:cNvPicPr>
@@ -7928,7 +7928,7 @@
       </p:sp>
       <p:pic>
         <p:nvPicPr>
-          <p:cNvPr id="16" name="Image 0" descr="C:\Users\Anastacia\.gemini\antigravity\brain\b231025d-bdec-4ae6-abf4-6612b4e70062\.user_uploaded\media_1791716440434_8726aec8.png">    </p:cNvPr>
+          <p:cNvPr id="16" name="Image 0" descr="C:\Users\Anastacia\.gemini\antigravity\brain\b231025d-bdec-4ae6-abf4-6612b4e70062\.user_uploaded\media_1791717818951_140b1a27.png">    </p:cNvPr>
           <p:cNvPicPr>
             <a:picLocks noChangeAspect="1"/>
           </p:cNvPicPr>
@@ -8572,7 +8572,7 @@
       </p:sp>
       <p:pic>
         <p:nvPicPr>
-          <p:cNvPr id="19" name="Image 0" descr="C:\Users\Anastacia\.gemini\antigravity\brain\b231025d-bdec-4ae6-abf4-6612b4e70062\.user_uploaded\media_1791716238254_2bb59ddd.png">    </p:cNvPr>
+          <p:cNvPr id="19" name="Image 0" descr="C:\Users\Anastacia\.gemini\antigravity\brain\b231025d-bdec-4ae6-abf4-6612b4e70062\.user_uploaded\media_1791717846173_09540310.png">    </p:cNvPr>
           <p:cNvPicPr>
             <a:picLocks noChangeAspect="1"/>
           </p:cNvPicPr>

</xml_diff>

<commit_message>
docs(pptx): update course/subject to CC316 (App Dev and Emerging Tech)
</commit_message>
<xml_diff>
--- a/TARIPA_Defense_Presentation.pptx
+++ b/TARIPA_Defense_Presentation.pptx
@@ -1685,7 +1685,7 @@
         <p:spPr>
           <a:xfrm>
             <a:off x="594360" y="594360"/>
-            <a:ext cx="2834640" cy="347472"/>
+            <a:ext cx="3108960" cy="347472"/>
           </a:xfrm>
           <a:prstGeom prst="roundRect">
             <a:avLst>
@@ -1712,7 +1712,7 @@
         <p:spPr>
           <a:xfrm>
             <a:off x="594360" y="594360"/>
-            <a:ext cx="2834640" cy="347472"/>
+            <a:ext cx="3108960" cy="347472"/>
           </a:xfrm>
           <a:prstGeom prst="rect">
             <a:avLst/>
@@ -1736,7 +1736,7 @@
                 <a:ea typeface="Segoe UI" pitchFamily="34" charset="-122"/>
                 <a:cs typeface="Segoe UI" pitchFamily="34" charset="-120"/>
               </a:rPr>
-              <a:t>IM 2 FINAL PROJECT DEFENSE</a:t>
+              <a:t>CC316 FINAL PROJECT DEFENSE</a:t>
             </a:r>
             <a:endParaRPr lang="en-US" sz="1000" dirty="0"/>
           </a:p>
@@ -1912,7 +1912,7 @@
         <p:spPr>
           <a:xfrm>
             <a:off x="822960" y="4572000"/>
-            <a:ext cx="4846320" cy="1417320"/>
+            <a:ext cx="4937760" cy="1417320"/>
           </a:xfrm>
           <a:prstGeom prst="rect">
             <a:avLst/>
@@ -1966,14 +1966,14 @@
                 <a:ea typeface="Segoe UI" pitchFamily="34" charset="-122"/>
                 <a:cs typeface="Segoe UI" pitchFamily="34" charset="-120"/>
               </a:rPr>
-              <a:t>COURSE &amp; INSTRUCTOR
+              <a:t>SUBJECT &amp; INSTRUCTOR
 </a:t>
             </a:r>
             <a:pPr indent="0" marL="0">
               <a:buNone/>
             </a:pPr>
             <a:r>
-              <a:rPr lang="en-US" sz="1300" b="1" dirty="0">
+              <a:rPr lang="en-US" sz="1250" b="1" dirty="0">
                 <a:solidFill>
                   <a:srgbClr val="E2E8F0"/>
                 </a:solidFill>
@@ -1981,7 +1981,7 @@
                 <a:ea typeface="Segoe UI" pitchFamily="34" charset="-122"/>
                 <a:cs typeface="Segoe UI" pitchFamily="34" charset="-120"/>
               </a:rPr>
-              <a:t>Information Management 2 (IM 2)  ·  Prof. Xerxes</a:t>
+              <a:t>CC316 (App Dev and Emerging Tech)  ·  Prof. Xerxes</a:t>
             </a:r>
             <a:endParaRPr lang="en-US" sz="950" dirty="0"/>
           </a:p>

</xml_diff>

<commit_message>
docs(pptx): use TARIPA Landing/Login screen on Slide 1 Title Slide
</commit_message>
<xml_diff>
--- a/TARIPA_Defense_Presentation.pptx
+++ b/TARIPA_Defense_Presentation.pptx
@@ -2016,7 +2016,7 @@
       </p:sp>
       <p:pic>
         <p:nvPicPr>
-          <p:cNvPr id="10" name="Image 0" descr="C:\Users\Anastacia\.gemini\antigravity\brain\b231025d-bdec-4ae6-abf4-6612b4e70062\.user_uploaded\media_1791717718314_44f510c9.png">    </p:cNvPr>
+          <p:cNvPr id="10" name="Image 0" descr="C:\Users\Anastacia\.gemini\antigravity\brain\b231025d-bdec-4ae6-abf4-6612b4e70062\.user_uploaded\media_1791718863296_f4eb3b46.png">    </p:cNvPr>
           <p:cNvPicPr>
             <a:picLocks noChangeAspect="1"/>
           </p:cNvPicPr>
@@ -8572,7 +8572,7 @@
       </p:sp>
       <p:pic>
         <p:nvPicPr>
-          <p:cNvPr id="19" name="Image 0" descr="C:\Users\Anastacia\.gemini\antigravity\brain\b231025d-bdec-4ae6-abf4-6612b4e70062\.user_uploaded\media_1791717846173_09540310.png">    </p:cNvPr>
+          <p:cNvPr id="19" name="Image 0" descr="C:\Users\Anastacia\.gemini\antigravity\brain\b231025d-bdec-4ae6-abf4-6612b4e70062\.user_uploaded\media_1791718863296_f4eb3b46.png">    </p:cNvPr>
           <p:cNvPicPr>
             <a:picLocks noChangeAspect="1"/>
           </p:cNvPicPr>

</xml_diff>

<commit_message>
docs(pptx): replace Slide 5 Tenants screenshot and enlarge image container for sharper readability
</commit_message>
<xml_diff>
--- a/TARIPA_Defense_Presentation.pptx
+++ b/TARIPA_Defense_Presentation.pptx
@@ -5466,11 +5466,11 @@
         <p:spPr>
           <a:xfrm>
             <a:off x="594360" y="1481328"/>
-            <a:ext cx="5623560" cy="877824"/>
+            <a:ext cx="4160520" cy="896112"/>
           </a:xfrm>
           <a:prstGeom prst="roundRect">
             <a:avLst>
-              <a:gd name="adj" fmla="val 12500"/>
+              <a:gd name="adj" fmla="val 12245"/>
             </a:avLst>
           </a:prstGeom>
           <a:solidFill>
@@ -5492,24 +5492,24 @@
         </p:nvSpPr>
         <p:spPr>
           <a:xfrm>
-            <a:off x="777240" y="1572768"/>
-            <a:ext cx="2834640" cy="274320"/>
-          </a:xfrm>
-          <a:prstGeom prst="rect">
-            <a:avLst/>
-          </a:prstGeom>
-          <a:noFill/>
-          <a:ln/>
-        </p:spPr>
-        <p:txBody>
-          <a:bodyPr wrap="square" rtlCol="0" anchor="ctr"/>
-          <a:lstStyle/>
-          <a:p>
-            <a:pPr indent="0" marL="0">
-              <a:buNone/>
-            </a:pPr>
-            <a:r>
-              <a:rPr lang="en-US" sz="1350" b="1" dirty="0">
+            <a:off x="749808" y="1554480"/>
+            <a:ext cx="2148840" cy="256032"/>
+          </a:xfrm>
+          <a:prstGeom prst="rect">
+            <a:avLst/>
+          </a:prstGeom>
+          <a:noFill/>
+          <a:ln/>
+        </p:spPr>
+        <p:txBody>
+          <a:bodyPr wrap="square" rtlCol="0" anchor="ctr"/>
+          <a:lstStyle/>
+          <a:p>
+            <a:pPr indent="0" marL="0">
+              <a:buNone/>
+            </a:pPr>
+            <a:r>
+              <a:rPr lang="en-US" sz="1200" b="1" dirty="0">
                 <a:solidFill>
                   <a:srgbClr val="1D4ED8"/>
                 </a:solidFill>
@@ -5519,7 +5519,7 @@
               </a:rPr>
               <a:t>1. rooms</a:t>
             </a:r>
-            <a:endParaRPr lang="en-US" sz="1350" dirty="0"/>
+            <a:endParaRPr lang="en-US" sz="1200" dirty="0"/>
           </a:p>
         </p:txBody>
       </p:sp>
@@ -5531,8 +5531,8 @@
         </p:nvSpPr>
         <p:spPr>
           <a:xfrm>
-            <a:off x="3108960" y="1591056"/>
-            <a:ext cx="2971800" cy="237744"/>
+            <a:off x="2286000" y="1572768"/>
+            <a:ext cx="2331720" cy="219456"/>
           </a:xfrm>
           <a:prstGeom prst="rect">
             <a:avLst/>
@@ -5548,7 +5548,7 @@
               <a:buNone/>
             </a:pPr>
             <a:r>
-              <a:rPr lang="en-US" sz="900" b="1" dirty="0">
+              <a:rPr lang="en-US" sz="800" b="1" dirty="0">
                 <a:solidFill>
                   <a:srgbClr val="059669"/>
                 </a:solidFill>
@@ -5558,7 +5558,7 @@
               </a:rPr>
               <a:t>PRIMARY ENTITY</a:t>
             </a:r>
-            <a:endParaRPr lang="en-US" sz="900" dirty="0"/>
+            <a:endParaRPr lang="en-US" sz="800" dirty="0"/>
           </a:p>
         </p:txBody>
       </p:sp>
@@ -5570,24 +5570,24 @@
         </p:nvSpPr>
         <p:spPr>
           <a:xfrm>
-            <a:off x="777240" y="1865376"/>
-            <a:ext cx="5257800" cy="411480"/>
-          </a:xfrm>
-          <a:prstGeom prst="rect">
-            <a:avLst/>
-          </a:prstGeom>
-          <a:noFill/>
-          <a:ln/>
-        </p:spPr>
-        <p:txBody>
-          <a:bodyPr wrap="square" rtlCol="0" anchor="ctr"/>
-          <a:lstStyle/>
-          <a:p>
-            <a:pPr indent="0" marL="0">
-              <a:buNone/>
-            </a:pPr>
-            <a:r>
-              <a:rPr lang="en-US" sz="1100" dirty="0">
+            <a:off x="749808" y="1828800"/>
+            <a:ext cx="3840480" cy="475488"/>
+          </a:xfrm>
+          <a:prstGeom prst="rect">
+            <a:avLst/>
+          </a:prstGeom>
+          <a:noFill/>
+          <a:ln/>
+        </p:spPr>
+        <p:txBody>
+          <a:bodyPr wrap="square" rtlCol="0" anchor="ctr"/>
+          <a:lstStyle/>
+          <a:p>
+            <a:pPr indent="0" marL="0">
+              <a:buNone/>
+            </a:pPr>
+            <a:r>
+              <a:rPr lang="en-US" sz="1020" dirty="0">
                 <a:solidFill>
                   <a:srgbClr val="475569"/>
                 </a:solidFill>
@@ -5597,7 +5597,7 @@
               </a:rPr>
               <a:t>Stores room_number (UNIQUE), capacity (1–30 beds, 6 rooms/floor), and monthly base rent.</a:t>
             </a:r>
-            <a:endParaRPr lang="en-US" sz="1100" dirty="0"/>
+            <a:endParaRPr lang="en-US" sz="1020" dirty="0"/>
           </a:p>
         </p:txBody>
       </p:sp>
@@ -5610,11 +5610,11 @@
         <p:spPr>
           <a:xfrm>
             <a:off x="594360" y="2468880"/>
-            <a:ext cx="5623560" cy="877824"/>
+            <a:ext cx="4160520" cy="896112"/>
           </a:xfrm>
           <a:prstGeom prst="roundRect">
             <a:avLst>
-              <a:gd name="adj" fmla="val 12500"/>
+              <a:gd name="adj" fmla="val 12245"/>
             </a:avLst>
           </a:prstGeom>
           <a:solidFill>
@@ -5636,24 +5636,24 @@
         </p:nvSpPr>
         <p:spPr>
           <a:xfrm>
-            <a:off x="777240" y="2560320"/>
-            <a:ext cx="2834640" cy="274320"/>
-          </a:xfrm>
-          <a:prstGeom prst="rect">
-            <a:avLst/>
-          </a:prstGeom>
-          <a:noFill/>
-          <a:ln/>
-        </p:spPr>
-        <p:txBody>
-          <a:bodyPr wrap="square" rtlCol="0" anchor="ctr"/>
-          <a:lstStyle/>
-          <a:p>
-            <a:pPr indent="0" marL="0">
-              <a:buNone/>
-            </a:pPr>
-            <a:r>
-              <a:rPr lang="en-US" sz="1350" b="1" dirty="0">
+            <a:off x="749808" y="2542032"/>
+            <a:ext cx="2148840" cy="256032"/>
+          </a:xfrm>
+          <a:prstGeom prst="rect">
+            <a:avLst/>
+          </a:prstGeom>
+          <a:noFill/>
+          <a:ln/>
+        </p:spPr>
+        <p:txBody>
+          <a:bodyPr wrap="square" rtlCol="0" anchor="ctr"/>
+          <a:lstStyle/>
+          <a:p>
+            <a:pPr indent="0" marL="0">
+              <a:buNone/>
+            </a:pPr>
+            <a:r>
+              <a:rPr lang="en-US" sz="1200" b="1" dirty="0">
                 <a:solidFill>
                   <a:srgbClr val="1D4ED8"/>
                 </a:solidFill>
@@ -5663,7 +5663,7 @@
               </a:rPr>
               <a:t>2. tenants</a:t>
             </a:r>
-            <a:endParaRPr lang="en-US" sz="1350" dirty="0"/>
+            <a:endParaRPr lang="en-US" sz="1200" dirty="0"/>
           </a:p>
         </p:txBody>
       </p:sp>
@@ -5675,8 +5675,8 @@
         </p:nvSpPr>
         <p:spPr>
           <a:xfrm>
-            <a:off x="3108960" y="2578608"/>
-            <a:ext cx="2971800" cy="237744"/>
+            <a:off x="2286000" y="2560320"/>
+            <a:ext cx="2331720" cy="219456"/>
           </a:xfrm>
           <a:prstGeom prst="rect">
             <a:avLst/>
@@ -5692,7 +5692,7 @@
               <a:buNone/>
             </a:pPr>
             <a:r>
-              <a:rPr lang="en-US" sz="900" b="1" dirty="0">
+              <a:rPr lang="en-US" sz="800" b="1" dirty="0">
                 <a:solidFill>
                   <a:srgbClr val="059669"/>
                 </a:solidFill>
@@ -5702,7 +5702,7 @@
               </a:rPr>
               <a:t>FK: room_id → rooms(id) ON DELETE SET NULL</a:t>
             </a:r>
-            <a:endParaRPr lang="en-US" sz="900" dirty="0"/>
+            <a:endParaRPr lang="en-US" sz="800" dirty="0"/>
           </a:p>
         </p:txBody>
       </p:sp>
@@ -5714,24 +5714,24 @@
         </p:nvSpPr>
         <p:spPr>
           <a:xfrm>
-            <a:off x="777240" y="2852928"/>
-            <a:ext cx="5257800" cy="411480"/>
-          </a:xfrm>
-          <a:prstGeom prst="rect">
-            <a:avLst/>
-          </a:prstGeom>
-          <a:noFill/>
-          <a:ln/>
-        </p:spPr>
-        <p:txBody>
-          <a:bodyPr wrap="square" rtlCol="0" anchor="ctr"/>
-          <a:lstStyle/>
-          <a:p>
-            <a:pPr indent="0" marL="0">
-              <a:buNone/>
-            </a:pPr>
-            <a:r>
-              <a:rPr lang="en-US" sz="1100" dirty="0">
+            <a:off x="749808" y="2816352"/>
+            <a:ext cx="3840480" cy="475488"/>
+          </a:xfrm>
+          <a:prstGeom prst="rect">
+            <a:avLst/>
+          </a:prstGeom>
+          <a:noFill/>
+          <a:ln/>
+        </p:spPr>
+        <p:txBody>
+          <a:bodyPr wrap="square" rtlCol="0" anchor="ctr"/>
+          <a:lstStyle/>
+          <a:p>
+            <a:pPr indent="0" marL="0">
+              <a:buNone/>
+            </a:pPr>
+            <a:r>
+              <a:rPr lang="en-US" sz="1020" dirty="0">
                 <a:solidFill>
                   <a:srgbClr val="475569"/>
                 </a:solidFill>
@@ -5741,7 +5741,7 @@
               </a:rPr>
               <a:t>Stores resident full_name, contact_number, move_in_date, and status (Active / Inactive).</a:t>
             </a:r>
-            <a:endParaRPr lang="en-US" sz="1100" dirty="0"/>
+            <a:endParaRPr lang="en-US" sz="1020" dirty="0"/>
           </a:p>
         </p:txBody>
       </p:sp>
@@ -5754,11 +5754,11 @@
         <p:spPr>
           <a:xfrm>
             <a:off x="594360" y="3456432"/>
-            <a:ext cx="5623560" cy="877824"/>
+            <a:ext cx="4160520" cy="896112"/>
           </a:xfrm>
           <a:prstGeom prst="roundRect">
             <a:avLst>
-              <a:gd name="adj" fmla="val 12500"/>
+              <a:gd name="adj" fmla="val 12245"/>
             </a:avLst>
           </a:prstGeom>
           <a:solidFill>
@@ -5780,24 +5780,24 @@
         </p:nvSpPr>
         <p:spPr>
           <a:xfrm>
-            <a:off x="777240" y="3547872"/>
-            <a:ext cx="2834640" cy="274320"/>
-          </a:xfrm>
-          <a:prstGeom prst="rect">
-            <a:avLst/>
-          </a:prstGeom>
-          <a:noFill/>
-          <a:ln/>
-        </p:spPr>
-        <p:txBody>
-          <a:bodyPr wrap="square" rtlCol="0" anchor="ctr"/>
-          <a:lstStyle/>
-          <a:p>
-            <a:pPr indent="0" marL="0">
-              <a:buNone/>
-            </a:pPr>
-            <a:r>
-              <a:rPr lang="en-US" sz="1350" b="1" dirty="0">
+            <a:off x="749808" y="3529584"/>
+            <a:ext cx="2148840" cy="256032"/>
+          </a:xfrm>
+          <a:prstGeom prst="rect">
+            <a:avLst/>
+          </a:prstGeom>
+          <a:noFill/>
+          <a:ln/>
+        </p:spPr>
+        <p:txBody>
+          <a:bodyPr wrap="square" rtlCol="0" anchor="ctr"/>
+          <a:lstStyle/>
+          <a:p>
+            <a:pPr indent="0" marL="0">
+              <a:buNone/>
+            </a:pPr>
+            <a:r>
+              <a:rPr lang="en-US" sz="1200" b="1" dirty="0">
                 <a:solidFill>
                   <a:srgbClr val="1D4ED8"/>
                 </a:solidFill>
@@ -5807,7 +5807,7 @@
               </a:rPr>
               <a:t>3. tenant_accounts</a:t>
             </a:r>
-            <a:endParaRPr lang="en-US" sz="1350" dirty="0"/>
+            <a:endParaRPr lang="en-US" sz="1200" dirty="0"/>
           </a:p>
         </p:txBody>
       </p:sp>
@@ -5819,8 +5819,8 @@
         </p:nvSpPr>
         <p:spPr>
           <a:xfrm>
-            <a:off x="3108960" y="3566160"/>
-            <a:ext cx="2971800" cy="237744"/>
+            <a:off x="2286000" y="3547872"/>
+            <a:ext cx="2331720" cy="219456"/>
           </a:xfrm>
           <a:prstGeom prst="rect">
             <a:avLst/>
@@ -5836,7 +5836,7 @@
               <a:buNone/>
             </a:pPr>
             <a:r>
-              <a:rPr lang="en-US" sz="900" b="1" dirty="0">
+              <a:rPr lang="en-US" sz="800" b="1" dirty="0">
                 <a:solidFill>
                   <a:srgbClr val="059669"/>
                 </a:solidFill>
@@ -5846,7 +5846,7 @@
               </a:rPr>
               <a:t>FK: tenant_id → tenants(id) ON DELETE CASCADE</a:t>
             </a:r>
-            <a:endParaRPr lang="en-US" sz="900" dirty="0"/>
+            <a:endParaRPr lang="en-US" sz="800" dirty="0"/>
           </a:p>
         </p:txBody>
       </p:sp>
@@ -5858,24 +5858,24 @@
         </p:nvSpPr>
         <p:spPr>
           <a:xfrm>
-            <a:off x="777240" y="3840480"/>
-            <a:ext cx="5257800" cy="411480"/>
-          </a:xfrm>
-          <a:prstGeom prst="rect">
-            <a:avLst/>
-          </a:prstGeom>
-          <a:noFill/>
-          <a:ln/>
-        </p:spPr>
-        <p:txBody>
-          <a:bodyPr wrap="square" rtlCol="0" anchor="ctr"/>
-          <a:lstStyle/>
-          <a:p>
-            <a:pPr indent="0" marL="0">
-              <a:buNone/>
-            </a:pPr>
-            <a:r>
-              <a:rPr lang="en-US" sz="1100" dirty="0">
+            <a:off x="749808" y="3803904"/>
+            <a:ext cx="3840480" cy="475488"/>
+          </a:xfrm>
+          <a:prstGeom prst="rect">
+            <a:avLst/>
+          </a:prstGeom>
+          <a:noFill/>
+          <a:ln/>
+        </p:spPr>
+        <p:txBody>
+          <a:bodyPr wrap="square" rtlCol="0" anchor="ctr"/>
+          <a:lstStyle/>
+          <a:p>
+            <a:pPr indent="0" marL="0">
+              <a:buNone/>
+            </a:pPr>
+            <a:r>
+              <a:rPr lang="en-US" sz="1020" dirty="0">
                 <a:solidFill>
                   <a:srgbClr val="475569"/>
                 </a:solidFill>
@@ -5885,7 +5885,7 @@
               </a:rPr>
               <a:t>1:1 credentials table storing auto-generated @username and BCrypt password_hash (10 salt rounds).</a:t>
             </a:r>
-            <a:endParaRPr lang="en-US" sz="1100" dirty="0"/>
+            <a:endParaRPr lang="en-US" sz="1020" dirty="0"/>
           </a:p>
         </p:txBody>
       </p:sp>
@@ -5898,11 +5898,11 @@
         <p:spPr>
           <a:xfrm>
             <a:off x="594360" y="4443984"/>
-            <a:ext cx="5623560" cy="877824"/>
+            <a:ext cx="4160520" cy="896112"/>
           </a:xfrm>
           <a:prstGeom prst="roundRect">
             <a:avLst>
-              <a:gd name="adj" fmla="val 12500"/>
+              <a:gd name="adj" fmla="val 12245"/>
             </a:avLst>
           </a:prstGeom>
           <a:solidFill>
@@ -5924,24 +5924,24 @@
         </p:nvSpPr>
         <p:spPr>
           <a:xfrm>
-            <a:off x="777240" y="4535424"/>
-            <a:ext cx="2834640" cy="274320"/>
-          </a:xfrm>
-          <a:prstGeom prst="rect">
-            <a:avLst/>
-          </a:prstGeom>
-          <a:noFill/>
-          <a:ln/>
-        </p:spPr>
-        <p:txBody>
-          <a:bodyPr wrap="square" rtlCol="0" anchor="ctr"/>
-          <a:lstStyle/>
-          <a:p>
-            <a:pPr indent="0" marL="0">
-              <a:buNone/>
-            </a:pPr>
-            <a:r>
-              <a:rPr lang="en-US" sz="1350" b="1" dirty="0">
+            <a:off x="749808" y="4517136"/>
+            <a:ext cx="2148840" cy="256032"/>
+          </a:xfrm>
+          <a:prstGeom prst="rect">
+            <a:avLst/>
+          </a:prstGeom>
+          <a:noFill/>
+          <a:ln/>
+        </p:spPr>
+        <p:txBody>
+          <a:bodyPr wrap="square" rtlCol="0" anchor="ctr"/>
+          <a:lstStyle/>
+          <a:p>
+            <a:pPr indent="0" marL="0">
+              <a:buNone/>
+            </a:pPr>
+            <a:r>
+              <a:rPr lang="en-US" sz="1200" b="1" dirty="0">
                 <a:solidFill>
                   <a:srgbClr val="1D4ED8"/>
                 </a:solidFill>
@@ -5951,7 +5951,7 @@
               </a:rPr>
               <a:t>4. utility_rates</a:t>
             </a:r>
-            <a:endParaRPr lang="en-US" sz="1350" dirty="0"/>
+            <a:endParaRPr lang="en-US" sz="1200" dirty="0"/>
           </a:p>
         </p:txBody>
       </p:sp>
@@ -5963,8 +5963,8 @@
         </p:nvSpPr>
         <p:spPr>
           <a:xfrm>
-            <a:off x="3108960" y="4553712"/>
-            <a:ext cx="2971800" cy="237744"/>
+            <a:off x="2286000" y="4535424"/>
+            <a:ext cx="2331720" cy="219456"/>
           </a:xfrm>
           <a:prstGeom prst="rect">
             <a:avLst/>
@@ -5980,7 +5980,7 @@
               <a:buNone/>
             </a:pPr>
             <a:r>
-              <a:rPr lang="en-US" sz="900" b="1" dirty="0">
+              <a:rPr lang="en-US" sz="800" b="1" dirty="0">
                 <a:solidFill>
                   <a:srgbClr val="059669"/>
                 </a:solidFill>
@@ -5990,7 +5990,7 @@
               </a:rPr>
               <a:t>LOOKUP ENTITY</a:t>
             </a:r>
-            <a:endParaRPr lang="en-US" sz="900" dirty="0"/>
+            <a:endParaRPr lang="en-US" sz="800" dirty="0"/>
           </a:p>
         </p:txBody>
       </p:sp>
@@ -6002,24 +6002,24 @@
         </p:nvSpPr>
         <p:spPr>
           <a:xfrm>
-            <a:off x="777240" y="4828032"/>
-            <a:ext cx="5257800" cy="411480"/>
-          </a:xfrm>
-          <a:prstGeom prst="rect">
-            <a:avLst/>
-          </a:prstGeom>
-          <a:noFill/>
-          <a:ln/>
-        </p:spPr>
-        <p:txBody>
-          <a:bodyPr wrap="square" rtlCol="0" anchor="ctr"/>
-          <a:lstStyle/>
-          <a:p>
-            <a:pPr indent="0" marL="0">
-              <a:buNone/>
-            </a:pPr>
-            <a:r>
-              <a:rPr lang="en-US" sz="1100" dirty="0">
+            <a:off x="749808" y="4791456"/>
+            <a:ext cx="3840480" cy="475488"/>
+          </a:xfrm>
+          <a:prstGeom prst="rect">
+            <a:avLst/>
+          </a:prstGeom>
+          <a:noFill/>
+          <a:ln/>
+        </p:spPr>
+        <p:txBody>
+          <a:bodyPr wrap="square" rtlCol="0" anchor="ctr"/>
+          <a:lstStyle/>
+          <a:p>
+            <a:pPr indent="0" marL="0">
+              <a:buNone/>
+            </a:pPr>
+            <a:r>
+              <a:rPr lang="en-US" sz="1020" dirty="0">
                 <a:solidFill>
                   <a:srgbClr val="475569"/>
                 </a:solidFill>
@@ -6029,7 +6029,7 @@
               </a:rPr>
               <a:t>Stores active Meralco Electricity (₱/kWh) and Maynilad Water (₱/Cu.M) tariff rates per unit.</a:t>
             </a:r>
-            <a:endParaRPr lang="en-US" sz="1100" dirty="0"/>
+            <a:endParaRPr lang="en-US" sz="1020" dirty="0"/>
           </a:p>
         </p:txBody>
       </p:sp>
@@ -6042,11 +6042,11 @@
         <p:spPr>
           <a:xfrm>
             <a:off x="594360" y="5431536"/>
-            <a:ext cx="5623560" cy="877824"/>
+            <a:ext cx="4160520" cy="896112"/>
           </a:xfrm>
           <a:prstGeom prst="roundRect">
             <a:avLst>
-              <a:gd name="adj" fmla="val 12500"/>
+              <a:gd name="adj" fmla="val 12245"/>
             </a:avLst>
           </a:prstGeom>
           <a:solidFill>
@@ -6068,24 +6068,24 @@
         </p:nvSpPr>
         <p:spPr>
           <a:xfrm>
-            <a:off x="777240" y="5522976"/>
-            <a:ext cx="2834640" cy="274320"/>
-          </a:xfrm>
-          <a:prstGeom prst="rect">
-            <a:avLst/>
-          </a:prstGeom>
-          <a:noFill/>
-          <a:ln/>
-        </p:spPr>
-        <p:txBody>
-          <a:bodyPr wrap="square" rtlCol="0" anchor="ctr"/>
-          <a:lstStyle/>
-          <a:p>
-            <a:pPr indent="0" marL="0">
-              <a:buNone/>
-            </a:pPr>
-            <a:r>
-              <a:rPr lang="en-US" sz="1350" b="1" dirty="0">
+            <a:off x="749808" y="5504688"/>
+            <a:ext cx="2148840" cy="256032"/>
+          </a:xfrm>
+          <a:prstGeom prst="rect">
+            <a:avLst/>
+          </a:prstGeom>
+          <a:noFill/>
+          <a:ln/>
+        </p:spPr>
+        <p:txBody>
+          <a:bodyPr wrap="square" rtlCol="0" anchor="ctr"/>
+          <a:lstStyle/>
+          <a:p>
+            <a:pPr indent="0" marL="0">
+              <a:buNone/>
+            </a:pPr>
+            <a:r>
+              <a:rPr lang="en-US" sz="1200" b="1" dirty="0">
                 <a:solidFill>
                   <a:srgbClr val="1D4ED8"/>
                 </a:solidFill>
@@ -6095,7 +6095,7 @@
               </a:rPr>
               <a:t>5. meter_readings &amp; billing_records</a:t>
             </a:r>
-            <a:endParaRPr lang="en-US" sz="1350" dirty="0"/>
+            <a:endParaRPr lang="en-US" sz="1200" dirty="0"/>
           </a:p>
         </p:txBody>
       </p:sp>
@@ -6107,8 +6107,8 @@
         </p:nvSpPr>
         <p:spPr>
           <a:xfrm>
-            <a:off x="3108960" y="5541264"/>
-            <a:ext cx="2971800" cy="237744"/>
+            <a:off x="2286000" y="5522976"/>
+            <a:ext cx="2331720" cy="219456"/>
           </a:xfrm>
           <a:prstGeom prst="rect">
             <a:avLst/>
@@ -6124,7 +6124,7 @@
               <a:buNone/>
             </a:pPr>
             <a:r>
-              <a:rPr lang="en-US" sz="900" b="1" dirty="0">
+              <a:rPr lang="en-US" sz="800" b="1" dirty="0">
                 <a:solidFill>
                   <a:srgbClr val="059669"/>
                 </a:solidFill>
@@ -6134,7 +6134,7 @@
               </a:rPr>
               <a:t>FK: tenant_id → tenants(id) ON DELETE CASCADE</a:t>
             </a:r>
-            <a:endParaRPr lang="en-US" sz="900" dirty="0"/>
+            <a:endParaRPr lang="en-US" sz="800" dirty="0"/>
           </a:p>
         </p:txBody>
       </p:sp>
@@ -6146,24 +6146,24 @@
         </p:nvSpPr>
         <p:spPr>
           <a:xfrm>
-            <a:off x="777240" y="5815584"/>
-            <a:ext cx="5257800" cy="411480"/>
-          </a:xfrm>
-          <a:prstGeom prst="rect">
-            <a:avLst/>
-          </a:prstGeom>
-          <a:noFill/>
-          <a:ln/>
-        </p:spPr>
-        <p:txBody>
-          <a:bodyPr wrap="square" rtlCol="0" anchor="ctr"/>
-          <a:lstStyle/>
-          <a:p>
-            <a:pPr indent="0" marL="0">
-              <a:buNone/>
-            </a:pPr>
-            <a:r>
-              <a:rPr lang="en-US" sz="1100" dirty="0">
+            <a:off x="749808" y="5779008"/>
+            <a:ext cx="3840480" cy="475488"/>
+          </a:xfrm>
+          <a:prstGeom prst="rect">
+            <a:avLst/>
+          </a:prstGeom>
+          <a:noFill/>
+          <a:ln/>
+        </p:spPr>
+        <p:txBody>
+          <a:bodyPr wrap="square" rtlCol="0" anchor="ctr"/>
+          <a:lstStyle/>
+          <a:p>
+            <a:pPr indent="0" marL="0">
+              <a:buNone/>
+            </a:pPr>
+            <a:r>
+              <a:rPr lang="en-US" sz="1020" dirty="0">
                 <a:solidFill>
                   <a:srgbClr val="475569"/>
                 </a:solidFill>
@@ -6173,7 +6173,7 @@
               </a:rPr>
               <a:t>Logs monthly PREV &amp; PRES sub-meter readings, computed kWh/Cu.M usage, itemized charges, and payment status.</a:t>
             </a:r>
-            <a:endParaRPr lang="en-US" sz="1100" dirty="0"/>
+            <a:endParaRPr lang="en-US" sz="1020" dirty="0"/>
           </a:p>
         </p:txBody>
       </p:sp>
@@ -6185,8 +6185,8 @@
         </p:nvSpPr>
         <p:spPr>
           <a:xfrm>
-            <a:off x="6400800" y="1481328"/>
-            <a:ext cx="5193792" cy="4846320"/>
+            <a:off x="4937760" y="1481328"/>
+            <a:ext cx="6656832" cy="4846320"/>
           </a:xfrm>
           <a:prstGeom prst="roundRect">
             <a:avLst>
@@ -6206,7 +6206,7 @@
       </p:sp>
       <p:pic>
         <p:nvPicPr>
-          <p:cNvPr id="27" name="Image 0" descr="C:\Users\Anastacia\.gemini\antigravity\brain\b231025d-bdec-4ae6-abf4-6612b4e70062\.user_uploaded\media_1791719256589_7d3eaed2.png">    </p:cNvPr>
+          <p:cNvPr id="27" name="Image 0" descr="C:\Users\Anastacia\.gemini\antigravity\brain\b231025d-bdec-4ae6-abf4-6612b4e70062\.user_uploaded\media_1791720462358_d8a01114.png">    </p:cNvPr>
           <p:cNvPicPr>
             <a:picLocks noChangeAspect="1"/>
           </p:cNvPicPr>
@@ -6219,8 +6219,8 @@
         </p:blipFill>
         <p:spPr>
           <a:xfrm>
-            <a:off x="6473952" y="1554480"/>
-            <a:ext cx="5047488" cy="4700016"/>
+            <a:off x="5010912" y="1554480"/>
+            <a:ext cx="6510528" cy="4700016"/>
           </a:xfrm>
           <a:prstGeom prst="rect">
             <a:avLst/>

</xml_diff>